<commit_message>
remake presentation + main readme
</commit_message>
<xml_diff>
--- a/week-4/presentation_short.pptx
+++ b/week-4/presentation_short.pptx
@@ -10,8 +10,10 @@
     <p:sldId id="264" r:id="rId4"/>
     <p:sldId id="265" r:id="rId5"/>
     <p:sldId id="266" r:id="rId6"/>
-    <p:sldId id="267" r:id="rId7"/>
-    <p:sldId id="268" r:id="rId8"/>
+    <p:sldId id="269" r:id="rId7"/>
+    <p:sldId id="270" r:id="rId8"/>
+    <p:sldId id="271" r:id="rId9"/>
+    <p:sldId id="268" r:id="rId10"/>
   </p:sldIdLst>
   <p:sldSz cx="12192000" cy="6858000"/>
   <p:notesSz cx="6858000" cy="9144000"/>
@@ -110,6 +112,11 @@
       </a:defRPr>
     </a:lvl9pPr>
   </p:defaultTextStyle>
+  <p:extLst>
+    <p:ext uri="{EFAFB233-063F-42B5-8137-9DF3F51BA10A}">
+      <p15:sldGuideLst xmlns:p15="http://schemas.microsoft.com/office/powerpoint/2012/main"/>
+    </p:ext>
+  </p:extLst>
 </p:presentation>
 </file>
 
@@ -244,7 +251,7 @@
           <a:p>
             <a:fld id="{B065FDBB-ACE0-45A8-82EC-1FA55A2A81A8}" type="datetimeFigureOut">
               <a:rPr lang="ru-RU" smtClean="0"/>
-              <a:t>22.09.2026</a:t>
+              <a:t>13.10.2026</a:t>
             </a:fld>
             <a:endParaRPr lang="ru-RU"/>
           </a:p>
@@ -414,7 +421,7 @@
           <a:p>
             <a:fld id="{B065FDBB-ACE0-45A8-82EC-1FA55A2A81A8}" type="datetimeFigureOut">
               <a:rPr lang="ru-RU" smtClean="0"/>
-              <a:t>22.09.2026</a:t>
+              <a:t>13.10.2026</a:t>
             </a:fld>
             <a:endParaRPr lang="ru-RU"/>
           </a:p>
@@ -594,7 +601,7 @@
           <a:p>
             <a:fld id="{B065FDBB-ACE0-45A8-82EC-1FA55A2A81A8}" type="datetimeFigureOut">
               <a:rPr lang="ru-RU" smtClean="0"/>
-              <a:t>22.09.2026</a:t>
+              <a:t>13.10.2026</a:t>
             </a:fld>
             <a:endParaRPr lang="ru-RU"/>
           </a:p>
@@ -764,7 +771,7 @@
           <a:p>
             <a:fld id="{B065FDBB-ACE0-45A8-82EC-1FA55A2A81A8}" type="datetimeFigureOut">
               <a:rPr lang="ru-RU" smtClean="0"/>
-              <a:t>22.09.2026</a:t>
+              <a:t>13.10.2026</a:t>
             </a:fld>
             <a:endParaRPr lang="ru-RU"/>
           </a:p>
@@ -1010,7 +1017,7 @@
           <a:p>
             <a:fld id="{B065FDBB-ACE0-45A8-82EC-1FA55A2A81A8}" type="datetimeFigureOut">
               <a:rPr lang="ru-RU" smtClean="0"/>
-              <a:t>22.09.2026</a:t>
+              <a:t>13.10.2026</a:t>
             </a:fld>
             <a:endParaRPr lang="ru-RU"/>
           </a:p>
@@ -1242,7 +1249,7 @@
           <a:p>
             <a:fld id="{B065FDBB-ACE0-45A8-82EC-1FA55A2A81A8}" type="datetimeFigureOut">
               <a:rPr lang="ru-RU" smtClean="0"/>
-              <a:t>22.09.2026</a:t>
+              <a:t>13.10.2026</a:t>
             </a:fld>
             <a:endParaRPr lang="ru-RU"/>
           </a:p>
@@ -1609,7 +1616,7 @@
           <a:p>
             <a:fld id="{B065FDBB-ACE0-45A8-82EC-1FA55A2A81A8}" type="datetimeFigureOut">
               <a:rPr lang="ru-RU" smtClean="0"/>
-              <a:t>22.09.2026</a:t>
+              <a:t>13.10.2026</a:t>
             </a:fld>
             <a:endParaRPr lang="ru-RU"/>
           </a:p>
@@ -1727,7 +1734,7 @@
           <a:p>
             <a:fld id="{B065FDBB-ACE0-45A8-82EC-1FA55A2A81A8}" type="datetimeFigureOut">
               <a:rPr lang="ru-RU" smtClean="0"/>
-              <a:t>22.09.2026</a:t>
+              <a:t>13.10.2026</a:t>
             </a:fld>
             <a:endParaRPr lang="ru-RU"/>
           </a:p>
@@ -1822,7 +1829,7 @@
           <a:p>
             <a:fld id="{B065FDBB-ACE0-45A8-82EC-1FA55A2A81A8}" type="datetimeFigureOut">
               <a:rPr lang="ru-RU" smtClean="0"/>
-              <a:t>22.09.2026</a:t>
+              <a:t>13.10.2026</a:t>
             </a:fld>
             <a:endParaRPr lang="ru-RU"/>
           </a:p>
@@ -2099,7 +2106,7 @@
           <a:p>
             <a:fld id="{B065FDBB-ACE0-45A8-82EC-1FA55A2A81A8}" type="datetimeFigureOut">
               <a:rPr lang="ru-RU" smtClean="0"/>
-              <a:t>22.09.2026</a:t>
+              <a:t>13.10.2026</a:t>
             </a:fld>
             <a:endParaRPr lang="ru-RU"/>
           </a:p>
@@ -2352,7 +2359,7 @@
           <a:p>
             <a:fld id="{B065FDBB-ACE0-45A8-82EC-1FA55A2A81A8}" type="datetimeFigureOut">
               <a:rPr lang="ru-RU" smtClean="0"/>
-              <a:t>22.09.2026</a:t>
+              <a:t>13.10.2026</a:t>
             </a:fld>
             <a:endParaRPr lang="ru-RU"/>
           </a:p>
@@ -2565,7 +2572,7 @@
           <a:p>
             <a:fld id="{B065FDBB-ACE0-45A8-82EC-1FA55A2A81A8}" type="datetimeFigureOut">
               <a:rPr lang="ru-RU" smtClean="0"/>
-              <a:t>22.09.2026</a:t>
+              <a:t>13.10.2026</a:t>
             </a:fld>
             <a:endParaRPr lang="ru-RU"/>
           </a:p>
@@ -3766,7 +3773,7 @@
         <p:spPr>
           <a:xfrm>
             <a:off x="0" y="0"/>
-            <a:ext cx="12192000" cy="6858000"/>
+            <a:ext cx="12192000" cy="6391373"/>
           </a:xfrm>
           <a:prstGeom prst="rect">
             <a:avLst/>
@@ -3789,8 +3796,164 @@
         </p:blipFill>
         <p:spPr>
           <a:xfrm>
-            <a:off x="1083508" y="5887279"/>
-            <a:ext cx="2543530" cy="514422"/>
+            <a:off x="0" y="6295947"/>
+            <a:ext cx="12192000" cy="562053"/>
+          </a:xfrm>
+          <a:prstGeom prst="rect">
+            <a:avLst/>
+          </a:prstGeom>
+        </p:spPr>
+      </p:pic>
+    </p:spTree>
+    <p:extLst>
+      <p:ext uri="{BB962C8B-B14F-4D97-AF65-F5344CB8AC3E}">
+        <p14:creationId xmlns:p14="http://schemas.microsoft.com/office/powerpoint/2010/main" val="3726045236"/>
+      </p:ext>
+    </p:extLst>
+  </p:cSld>
+  <p:clrMapOvr>
+    <a:masterClrMapping/>
+  </p:clrMapOvr>
+</p:sld>
+</file>
+
+<file path=ppt/slides/slide7.xml><?xml version="1.0" encoding="utf-8"?>
+<p:sld xmlns:a="http://schemas.openxmlformats.org/drawingml/2006/main" xmlns:r="http://schemas.openxmlformats.org/officeDocument/2006/relationships" xmlns:p="http://schemas.openxmlformats.org/presentationml/2006/main">
+  <p:cSld>
+    <p:spTree>
+      <p:nvGrpSpPr>
+        <p:cNvPr id="1" name=""/>
+        <p:cNvGrpSpPr/>
+        <p:nvPr/>
+      </p:nvGrpSpPr>
+      <p:grpSpPr>
+        <a:xfrm>
+          <a:off x="0" y="0"/>
+          <a:ext cx="0" cy="0"/>
+          <a:chOff x="0" y="0"/>
+          <a:chExt cx="0" cy="0"/>
+        </a:xfrm>
+      </p:grpSpPr>
+      <p:pic>
+        <p:nvPicPr>
+          <p:cNvPr id="2" name="Рисунок 1"/>
+          <p:cNvPicPr>
+            <a:picLocks noChangeAspect="1"/>
+          </p:cNvPicPr>
+          <p:nvPr/>
+        </p:nvPicPr>
+        <p:blipFill>
+          <a:blip r:embed="rId2"/>
+          <a:stretch>
+            <a:fillRect/>
+          </a:stretch>
+        </p:blipFill>
+        <p:spPr>
+          <a:xfrm>
+            <a:off x="0" y="0"/>
+            <a:ext cx="12192000" cy="6289964"/>
+          </a:xfrm>
+          <a:prstGeom prst="rect">
+            <a:avLst/>
+          </a:prstGeom>
+        </p:spPr>
+      </p:pic>
+      <p:pic>
+        <p:nvPicPr>
+          <p:cNvPr id="3" name="Рисунок 2"/>
+          <p:cNvPicPr>
+            <a:picLocks noChangeAspect="1"/>
+          </p:cNvPicPr>
+          <p:nvPr/>
+        </p:nvPicPr>
+        <p:blipFill>
+          <a:blip r:embed="rId3"/>
+          <a:stretch>
+            <a:fillRect/>
+          </a:stretch>
+        </p:blipFill>
+        <p:spPr>
+          <a:xfrm>
+            <a:off x="0" y="6153052"/>
+            <a:ext cx="12192000" cy="704948"/>
+          </a:xfrm>
+          <a:prstGeom prst="rect">
+            <a:avLst/>
+          </a:prstGeom>
+        </p:spPr>
+      </p:pic>
+    </p:spTree>
+    <p:extLst>
+      <p:ext uri="{BB962C8B-B14F-4D97-AF65-F5344CB8AC3E}">
+        <p14:creationId xmlns:p14="http://schemas.microsoft.com/office/powerpoint/2010/main" val="4065247529"/>
+      </p:ext>
+    </p:extLst>
+  </p:cSld>
+  <p:clrMapOvr>
+    <a:masterClrMapping/>
+  </p:clrMapOvr>
+</p:sld>
+</file>
+
+<file path=ppt/slides/slide8.xml><?xml version="1.0" encoding="utf-8"?>
+<p:sld xmlns:a="http://schemas.openxmlformats.org/drawingml/2006/main" xmlns:r="http://schemas.openxmlformats.org/officeDocument/2006/relationships" xmlns:p="http://schemas.openxmlformats.org/presentationml/2006/main">
+  <p:cSld>
+    <p:spTree>
+      <p:nvGrpSpPr>
+        <p:cNvPr id="1" name=""/>
+        <p:cNvGrpSpPr/>
+        <p:nvPr/>
+      </p:nvGrpSpPr>
+      <p:grpSpPr>
+        <a:xfrm>
+          <a:off x="0" y="0"/>
+          <a:ext cx="0" cy="0"/>
+          <a:chOff x="0" y="0"/>
+          <a:chExt cx="0" cy="0"/>
+        </a:xfrm>
+      </p:grpSpPr>
+      <p:pic>
+        <p:nvPicPr>
+          <p:cNvPr id="2" name="Рисунок 1"/>
+          <p:cNvPicPr>
+            <a:picLocks noChangeAspect="1"/>
+          </p:cNvPicPr>
+          <p:nvPr/>
+        </p:nvPicPr>
+        <p:blipFill>
+          <a:blip r:embed="rId2"/>
+          <a:stretch>
+            <a:fillRect/>
+          </a:stretch>
+        </p:blipFill>
+        <p:spPr>
+          <a:xfrm>
+            <a:off x="0" y="17652"/>
+            <a:ext cx="12192000" cy="6870198"/>
+          </a:xfrm>
+          <a:prstGeom prst="rect">
+            <a:avLst/>
+          </a:prstGeom>
+        </p:spPr>
+      </p:pic>
+      <p:pic>
+        <p:nvPicPr>
+          <p:cNvPr id="3" name="Рисунок 2"/>
+          <p:cNvPicPr>
+            <a:picLocks noChangeAspect="1"/>
+          </p:cNvPicPr>
+          <p:nvPr/>
+        </p:nvPicPr>
+        <p:blipFill>
+          <a:blip r:embed="rId3"/>
+          <a:stretch>
+            <a:fillRect/>
+          </a:stretch>
+        </p:blipFill>
+        <p:spPr>
+          <a:xfrm>
+            <a:off x="10714182" y="6353991"/>
+            <a:ext cx="1413163" cy="401883"/>
           </a:xfrm>
           <a:prstGeom prst="rect">
             <a:avLst/>
@@ -3813,8 +3976,8 @@
         </p:blipFill>
         <p:spPr>
           <a:xfrm>
-            <a:off x="344725" y="6095894"/>
-            <a:ext cx="874474" cy="762106"/>
+            <a:off x="187239" y="6353991"/>
+            <a:ext cx="7421011" cy="266737"/>
           </a:xfrm>
           <a:prstGeom prst="rect">
             <a:avLst/>
@@ -3823,7 +3986,7 @@
       </p:pic>
       <p:pic>
         <p:nvPicPr>
-          <p:cNvPr id="5" name="Рисунок 4"/>
+          <p:cNvPr id="6" name="Рисунок 5"/>
           <p:cNvPicPr>
             <a:picLocks noChangeAspect="1"/>
           </p:cNvPicPr>
@@ -3837,8 +4000,8 @@
         </p:blipFill>
         <p:spPr>
           <a:xfrm>
-            <a:off x="344725" y="5467927"/>
-            <a:ext cx="3478823" cy="1390073"/>
+            <a:off x="489229" y="2363752"/>
+            <a:ext cx="4923280" cy="979812"/>
           </a:xfrm>
           <a:prstGeom prst="rect">
             <a:avLst/>
@@ -3847,7 +4010,31 @@
       </p:pic>
       <p:pic>
         <p:nvPicPr>
-          <p:cNvPr id="6" name="Рисунок 5"/>
+          <p:cNvPr id="7" name="Рисунок 6"/>
+          <p:cNvPicPr>
+            <a:picLocks noChangeAspect="1"/>
+          </p:cNvPicPr>
+          <p:nvPr/>
+        </p:nvPicPr>
+        <p:blipFill>
+          <a:blip r:embed="rId5"/>
+          <a:stretch>
+            <a:fillRect/>
+          </a:stretch>
+        </p:blipFill>
+        <p:spPr>
+          <a:xfrm>
+            <a:off x="7859549" y="6194869"/>
+            <a:ext cx="4267796" cy="318244"/>
+          </a:xfrm>
+          <a:prstGeom prst="rect">
+            <a:avLst/>
+          </a:prstGeom>
+        </p:spPr>
+      </p:pic>
+      <p:pic>
+        <p:nvPicPr>
+          <p:cNvPr id="8" name="Рисунок 7"/>
           <p:cNvPicPr>
             <a:picLocks noChangeAspect="1"/>
           </p:cNvPicPr>
@@ -3861,8 +4048,8 @@
         </p:blipFill>
         <p:spPr>
           <a:xfrm>
-            <a:off x="11718675" y="6162963"/>
-            <a:ext cx="473325" cy="695037"/>
+            <a:off x="489229" y="4477563"/>
+            <a:ext cx="190527" cy="371527"/>
           </a:xfrm>
           <a:prstGeom prst="rect">
             <a:avLst/>
@@ -3871,7 +4058,7 @@
       </p:pic>
       <p:pic>
         <p:nvPicPr>
-          <p:cNvPr id="7" name="Рисунок 6"/>
+          <p:cNvPr id="10" name="Рисунок 9"/>
           <p:cNvPicPr>
             <a:picLocks noChangeAspect="1"/>
           </p:cNvPicPr>
@@ -3885,32 +4072,8 @@
         </p:blipFill>
         <p:spPr>
           <a:xfrm>
-            <a:off x="11272520" y="6245798"/>
-            <a:ext cx="405515" cy="612202"/>
-          </a:xfrm>
-          <a:prstGeom prst="rect">
-            <a:avLst/>
-          </a:prstGeom>
-        </p:spPr>
-      </p:pic>
-      <p:pic>
-        <p:nvPicPr>
-          <p:cNvPr id="8" name="Рисунок 7"/>
-          <p:cNvPicPr>
-            <a:picLocks noChangeAspect="1"/>
-          </p:cNvPicPr>
-          <p:nvPr/>
-        </p:nvPicPr>
-        <p:blipFill>
-          <a:blip r:embed="rId8"/>
-          <a:stretch>
-            <a:fillRect/>
-          </a:stretch>
-        </p:blipFill>
-        <p:spPr>
-          <a:xfrm>
-            <a:off x="0" y="6134964"/>
-            <a:ext cx="304085" cy="533474"/>
+            <a:off x="0" y="-32121"/>
+            <a:ext cx="12192000" cy="6388101"/>
           </a:xfrm>
           <a:prstGeom prst="rect">
             <a:avLst/>
@@ -3920,24 +4083,17 @@
     </p:spTree>
     <p:extLst>
       <p:ext uri="{BB962C8B-B14F-4D97-AF65-F5344CB8AC3E}">
-        <p14:creationId xmlns:p14="http://schemas.microsoft.com/office/powerpoint/2010/main" val="2341906483"/>
+        <p14:creationId xmlns:p14="http://schemas.microsoft.com/office/powerpoint/2010/main" val="2364356075"/>
       </p:ext>
     </p:extLst>
   </p:cSld>
   <p:clrMapOvr>
     <a:masterClrMapping/>
   </p:clrMapOvr>
-  <p:timing>
-    <p:tnLst>
-      <p:par>
-        <p:cTn id="1" dur="indefinite" restart="never" nodeType="tmRoot"/>
-      </p:par>
-    </p:tnLst>
-  </p:timing>
 </p:sld>
 </file>
 
-<file path=ppt/slides/slide7.xml><?xml version="1.0" encoding="utf-8"?>
+<file path=ppt/slides/slide9.xml><?xml version="1.0" encoding="utf-8"?>
 <p:sld xmlns:a="http://schemas.openxmlformats.org/drawingml/2006/main" xmlns:r="http://schemas.openxmlformats.org/officeDocument/2006/relationships" xmlns:p="http://schemas.openxmlformats.org/presentationml/2006/main">
   <p:cSld>
     <p:spTree>

</xml_diff>